<commit_message>
Rewrite every doc and the deck in first person
Same facts, same scope, same numbers - just written the way I'd
actually explain it, not narrated as a third-party report.

Co-Authored-By: Claude Sonnet 5 <noreply@anthropic.com>
</commit_message>
<xml_diff>
--- a/scoping-pack/Portage-AI-Scoping-Pack.pptx
+++ b/scoping-pack/Portage-AI-Scoping-Pack.pptx
@@ -2169,7 +2169,7 @@
                 <a:ea typeface="Cambria" pitchFamily="34" charset="-122"/>
                 <a:cs typeface="Cambria" pitchFamily="34" charset="-120"/>
               </a:rPr>
-              <a:t>Why a freight operations copilot</a:t>
+              <a:t>Why I built a freight operations copilot</a:t>
             </a:r>
             <a:endParaRPr lang="en-US" sz="3000" dirty="0"/>
           </a:p>
@@ -2208,7 +2208,7 @@
                 <a:ea typeface="Calibri" pitchFamily="34" charset="-122"/>
                 <a:cs typeface="Calibri" pitchFamily="34" charset="-120"/>
               </a:rPr>
-              <a:t>The brief fixes the domain — an AI-first agentic logistics app. “Logistics” is broad enough to hide the real question, so this POC narrows to one sharp vertical rather than a generic tracker.</a:t>
+              <a:t>The brief fixes the domain — an AI-first agentic logistics app. “Logistics” is broad enough to hide the real question, so I narrowed this POC to one sharp vertical instead of a generic tracker.</a:t>
             </a:r>
             <a:endParaRPr lang="en-US" sz="1300" dirty="0"/>
           </a:p>
@@ -2903,7 +2903,7 @@
                 <a:ea typeface="Calibri" pitchFamily="34" charset="-122"/>
                 <a:cs typeface="Calibri" pitchFamily="34" charset="-120"/>
               </a:rPr>
-              <a:t>Narrow to a freight / parcel operations copilot — the sharpest small system to prove exactly what this role asks for:</a:t>
+              <a:t>I narrowed this to a freight / parcel operations copilot — the sharpest small system to prove exactly what this role is testing for:</a:t>
             </a:r>
             <a:endParaRPr lang="en-US" sz="1250" dirty="0"/>
           </a:p>
@@ -3308,7 +3308,7 @@
                 <a:ea typeface="Calibri" pitchFamily="34" charset="-122"/>
                 <a:cs typeface="Calibri" pitchFamily="34" charset="-120"/>
               </a:rPr>
-              <a:t>Every mocked tool call in the prototype maps to a named real integration — see the repo's docs/AGENTS.md.</a:t>
+              <a:t>Every mocked tool call in the prototype maps to a named real integration — it's all in docs/AGENTS.md.</a:t>
             </a:r>
             <a:endParaRPr lang="en-US" sz="1100" dirty="0"/>
           </a:p>
@@ -9700,7 +9700,7 @@
                 <a:ea typeface="Calibri" pitchFamily="34" charset="-122"/>
                 <a:cs typeface="Calibri" pitchFamily="34" charset="-120"/>
               </a:rPr>
-              <a:t>Nothing here is a fake capability invented for the demo.  </a:t>
+              <a:t>Nothing here is a capability I invented for the demo.  </a:t>
             </a:r>
             <a:pPr indent="0" marL="0">
               <a:buNone/>
@@ -9714,7 +9714,7 @@
                 <a:ea typeface="Calibri" pitchFamily="34" charset="-122"/>
                 <a:cs typeface="Calibri" pitchFamily="34" charset="-120"/>
               </a:rPr>
-              <a:t>Every mocked tool call in the prototype maps to a named real integration point — the path from POC to pilot is a list of integrations, not a redesign. All three agents read and write one shipment record, and every escalation lands in one human queue with the same shape: option(s), rationale, cost/risk delta.</a:t>
+              <a:t>Every mocked tool call in the prototype maps to a named real integration point — getting from this POC to a pilot is a list of integrations, not a redesign. All three agents read and write one shipment record, and every escalation lands in one human queue with the same shape: option(s), rationale, cost/risk delta.</a:t>
             </a:r>
             <a:endParaRPr lang="en-US" sz="1150" dirty="0"/>
           </a:p>

</xml_diff>

<commit_message>
Update contact email to dijaedadula@gmail.com
Co-Authored-By: Claude Sonnet 5 <noreply@anthropic.com>
</commit_message>
<xml_diff>
--- a/scoping-pack/Portage-AI-Scoping-Pack.pptx
+++ b/scoping-pack/Portage-AI-Scoping-Pack.pptx
@@ -2066,7 +2066,7 @@
                 <a:ea typeface="Calibri" pitchFamily="34" charset="-122"/>
                 <a:cs typeface="Calibri" pitchFamily="34" charset="-120"/>
               </a:rPr>
-              <a:t>Dijae  ·  dijae0@gmail.com  ·  September 2026</a:t>
+              <a:t>Dijae  ·  dijaedadula@gmail.com  ·  September 2026</a:t>
             </a:r>
             <a:endParaRPr lang="en-US" sz="1100" dirty="0"/>
           </a:p>
@@ -13225,7 +13225,7 @@
                 <a:ea typeface="Calibri" pitchFamily="34" charset="-122"/>
                 <a:cs typeface="Calibri" pitchFamily="34" charset="-120"/>
               </a:rPr>
-              <a:t>Dijae  ·  dijae0@gmail.com</a:t>
+              <a:t>Dijae  ·  dijaedadula@gmail.com</a:t>
             </a:r>
             <a:endParaRPr lang="en-US" sz="1250" dirty="0"/>
           </a:p>

</xml_diff>